<commit_message>
Release v0.4 with animated inline answers
</commit_message>
<xml_diff>
--- a/mypaper_clean_no_answers.pptx
+++ b/mypaper_clean_no_answers.pptx
@@ -11039,8 +11039,32 @@
         </p:blipFill>
         <p:spPr>
           <a:xfrm>
-            <a:off x="3515426" y="4307840"/>
-            <a:ext cx="5161147" cy="2194560"/>
+            <a:off x="2766059" y="5107940"/>
+            <a:ext cx="4469891" cy="1661159"/>
+          </a:xfrm>
+          <a:prstGeom prst="rect">
+            <a:avLst/>
+          </a:prstGeom>
+        </p:spPr>
+      </p:pic>
+      <p:pic>
+        <p:nvPicPr>
+          <p:cNvPr id="4" name="Picture 3" descr="image.jpg"/>
+          <p:cNvPicPr>
+            <a:picLocks noChangeAspect="1"/>
+          </p:cNvPicPr>
+          <p:nvPr/>
+        </p:nvPicPr>
+        <p:blipFill>
+          <a:blip r:embed="rId3"/>
+          <a:stretch>
+            <a:fillRect/>
+          </a:stretch>
+        </p:blipFill>
+        <p:spPr>
+          <a:xfrm>
+            <a:off x="7388351" y="5296916"/>
+            <a:ext cx="2037588" cy="1283208"/>
           </a:xfrm>
           <a:prstGeom prst="rect">
             <a:avLst/>
@@ -11074,7 +11098,7 @@
         <p:spPr>
           <a:xfrm>
             <a:off x="711200" y="355600"/>
-            <a:ext cx="10769599" cy="3733799"/>
+            <a:ext cx="10769599" cy="6146800"/>
           </a:xfrm>
           <a:prstGeom prst="rect">
             <a:avLst/>
@@ -11161,30 +11185,6 @@
           </a:p>
         </p:txBody>
       </p:sp>
-      <p:pic>
-        <p:nvPicPr>
-          <p:cNvPr id="3" name="Picture 2" descr="image.jpg"/>
-          <p:cNvPicPr>
-            <a:picLocks noChangeAspect="1"/>
-          </p:cNvPicPr>
-          <p:nvPr/>
-        </p:nvPicPr>
-        <p:blipFill>
-          <a:blip r:embed="rId2"/>
-          <a:stretch>
-            <a:fillRect/>
-          </a:stretch>
-        </p:blipFill>
-        <p:spPr>
-          <a:xfrm>
-            <a:off x="5087388" y="4307840"/>
-            <a:ext cx="2017221" cy="2194560"/>
-          </a:xfrm>
-          <a:prstGeom prst="rect">
-            <a:avLst/>
-          </a:prstGeom>
-        </p:spPr>
-      </p:pic>
     </p:spTree>
   </p:cSld>
   <p:clrMapOvr>
@@ -12359,7 +12359,7 @@
         <p:spPr>
           <a:xfrm>
             <a:off x="711200" y="355600"/>
-            <a:ext cx="10769599" cy="6146800"/>
+            <a:ext cx="10769599" cy="3733799"/>
           </a:xfrm>
           <a:prstGeom prst="rect">
             <a:avLst/>
@@ -12463,6 +12463,30 @@
           </a:p>
         </p:txBody>
       </p:sp>
+      <p:pic>
+        <p:nvPicPr>
+          <p:cNvPr id="3" name="Picture 2" descr="image.jpg"/>
+          <p:cNvPicPr>
+            <a:picLocks noChangeAspect="1"/>
+          </p:cNvPicPr>
+          <p:nvPr/>
+        </p:nvPicPr>
+        <p:blipFill>
+          <a:blip r:embed="rId2"/>
+          <a:stretch>
+            <a:fillRect/>
+          </a:stretch>
+        </p:blipFill>
+        <p:spPr>
+          <a:xfrm>
+            <a:off x="4922519" y="4922773"/>
+            <a:ext cx="2346960" cy="1784604"/>
+          </a:xfrm>
+          <a:prstGeom prst="rect">
+            <a:avLst/>
+          </a:prstGeom>
+        </p:spPr>
+      </p:pic>
     </p:spTree>
   </p:cSld>
   <p:clrMapOvr>
@@ -12624,6 +12648,179 @@
         <p:spPr>
           <a:xfrm>
             <a:off x="711200" y="355600"/>
+            <a:ext cx="10769599" cy="6146800"/>
+          </a:xfrm>
+          <a:prstGeom prst="rect">
+            <a:avLst/>
+          </a:prstGeom>
+          <a:noFill/>
+        </p:spPr>
+        <p:txBody>
+          <a:bodyPr wrap="square" lIns="101600" rIns="101600" tIns="38100" bIns="38100" anchor="t">
+            <a:normAutofit/>
+          </a:bodyPr>
+          <a:lstStyle/>
+          <a:p>
+            <a:pPr algn="l">
+              <a:lnSpc>
+                <a:spcPct val="100000"/>
+              </a:lnSpc>
+              <a:spcBef>
+                <a:spcPts val="0"/>
+              </a:spcBef>
+              <a:spcAft>
+                <a:spcPts val="500"/>
+              </a:spcAft>
+            </a:pPr>
+            <a:r>
+              <a:rPr sz="2200" b="0" i="0">
+                <a:solidFill>
+                  <a:srgbClr val="000000"/>
+                </a:solidFill>
+                <a:latin typeface="SimSun"/>
+              </a:rPr>
+              <a:t>具体要求：题目与提纲相符合；在提纲中注明详略安排；详细发言的部分，要体现出对至少两个不同材料的综合运用。</a:t>
+            </a:r>
+          </a:p>
+          <a:p>
+            <a:pPr algn="l">
+              <a:lnSpc>
+                <a:spcPct val="100000"/>
+              </a:lnSpc>
+              <a:spcBef>
+                <a:spcPts val="0"/>
+              </a:spcBef>
+              <a:spcAft>
+                <a:spcPts val="500"/>
+              </a:spcAft>
+            </a:pPr>
+            <a:r>
+              <a:rPr sz="2500" b="1" i="0">
+                <a:solidFill>
+                  <a:srgbClr val="000000"/>
+                </a:solidFill>
+                <a:latin typeface="SimSun"/>
+              </a:rPr>
+              <a:t>题目:《》</a:t>
+            </a:r>
+          </a:p>
+          <a:p>
+            <a:pPr algn="l">
+              <a:lnSpc>
+                <a:spcPct val="100000"/>
+              </a:lnSpc>
+              <a:spcBef>
+                <a:spcPts val="0"/>
+              </a:spcBef>
+              <a:spcAft>
+                <a:spcPts val="500"/>
+              </a:spcAft>
+            </a:pPr>
+            <a:r>
+              <a:rPr sz="2500" b="1" i="0">
+                <a:solidFill>
+                  <a:srgbClr val="000000"/>
+                </a:solidFill>
+                <a:latin typeface="SimSun"/>
+              </a:rPr>
+              <a:t>提纲</a:t>
+            </a:r>
+          </a:p>
+          <a:p>
+            <a:pPr algn="l">
+              <a:lnSpc>
+                <a:spcPct val="100000"/>
+              </a:lnSpc>
+              <a:spcBef>
+                <a:spcPts val="0"/>
+              </a:spcBef>
+              <a:spcAft>
+                <a:spcPts val="500"/>
+              </a:spcAft>
+            </a:pPr>
+            <a:r>
+              <a:rPr sz="2200" b="0" i="0">
+                <a:solidFill>
+                  <a:srgbClr val="000000"/>
+                </a:solidFill>
+                <a:latin typeface="SimSun"/>
+              </a:rPr>
+              <a:t>【巩固训练】阅读下面两则材料，完成练习。</a:t>
+            </a:r>
+          </a:p>
+          <a:p>
+            <a:pPr algn="l">
+              <a:lnSpc>
+                <a:spcPct val="100000"/>
+              </a:lnSpc>
+              <a:spcBef>
+                <a:spcPts val="0"/>
+              </a:spcBef>
+              <a:spcAft>
+                <a:spcPts val="500"/>
+              </a:spcAft>
+            </a:pPr>
+            <a:r>
+              <a:rPr sz="2200" b="0" i="0">
+                <a:solidFill>
+                  <a:srgbClr val="000000"/>
+                </a:solidFill>
+                <a:latin typeface="SimSun"/>
+              </a:rPr>
+              <a:t>【材料一】</a:t>
+            </a:r>
+          </a:p>
+          <a:p>
+            <a:pPr algn="l">
+              <a:lnSpc>
+                <a:spcPct val="100000"/>
+              </a:lnSpc>
+              <a:spcBef>
+                <a:spcPts val="0"/>
+              </a:spcBef>
+              <a:spcAft>
+                <a:spcPts val="500"/>
+              </a:spcAft>
+            </a:pPr>
+            <a:r>
+              <a:rPr sz="2200" b="0" i="0">
+                <a:solidFill>
+                  <a:srgbClr val="000000"/>
+                </a:solidFill>
+                <a:latin typeface="SimSun"/>
+              </a:rPr>
+              <a:t>【图表占位：请参照原 PDF 图表】</a:t>
+            </a:r>
+          </a:p>
+        </p:txBody>
+      </p:sp>
+    </p:spTree>
+  </p:cSld>
+  <p:clrMapOvr>
+    <a:masterClrMapping/>
+  </p:clrMapOvr>
+</p:sld>
+</file>
+
+<file path=ppt/slides/slide57.xml><?xml version="1.0" encoding="utf-8"?>
+<p:sld xmlns:a="http://schemas.openxmlformats.org/drawingml/2006/main" xmlns:p="http://schemas.openxmlformats.org/presentationml/2006/main" xmlns:r="http://schemas.openxmlformats.org/officeDocument/2006/relationships">
+  <p:cSld>
+    <p:spTree>
+      <p:nvGrpSpPr>
+        <p:cNvPr id="1" name=""/>
+        <p:cNvGrpSpPr/>
+        <p:nvPr/>
+      </p:nvGrpSpPr>
+      <p:grpSpPr/>
+      <p:sp>
+        <p:nvSpPr>
+          <p:cNvPr id="2" name="TextBox 1"/>
+          <p:cNvSpPr txBox="1"/>
+          <p:nvPr/>
+        </p:nvSpPr>
+        <p:spPr>
+          <a:xfrm>
+            <a:off x="711200" y="355600"/>
             <a:ext cx="10769599" cy="3733799"/>
           </a:xfrm>
           <a:prstGeom prst="rect">
@@ -12655,51 +12852,7 @@
                 </a:solidFill>
                 <a:latin typeface="SimSun"/>
               </a:rPr>
-              <a:t>具体要求：题目与提纲相符合；在提纲中注明详略安排；详细发言的部分，要体现出对至少两个不同材料的综合运用。</a:t>
-            </a:r>
-          </a:p>
-          <a:p>
-            <a:pPr algn="l">
-              <a:lnSpc>
-                <a:spcPct val="100000"/>
-              </a:lnSpc>
-              <a:spcBef>
-                <a:spcPts val="0"/>
-              </a:spcBef>
-              <a:spcAft>
-                <a:spcPts val="500"/>
-              </a:spcAft>
-            </a:pPr>
-            <a:r>
-              <a:rPr sz="2500" b="1" i="0">
-                <a:solidFill>
-                  <a:srgbClr val="000000"/>
-                </a:solidFill>
-                <a:latin typeface="SimSun"/>
-              </a:rPr>
-              <a:t>题目:《》</a:t>
-            </a:r>
-          </a:p>
-          <a:p>
-            <a:pPr algn="l">
-              <a:lnSpc>
-                <a:spcPct val="100000"/>
-              </a:lnSpc>
-              <a:spcBef>
-                <a:spcPts val="0"/>
-              </a:spcBef>
-              <a:spcAft>
-                <a:spcPts val="500"/>
-              </a:spcAft>
-            </a:pPr>
-            <a:r>
-              <a:rPr sz="2500" b="1" i="0">
-                <a:solidFill>
-                  <a:srgbClr val="000000"/>
-                </a:solidFill>
-                <a:latin typeface="SimSun"/>
-              </a:rPr>
-              <a:t>提纲</a:t>
+              <a:t>为什么选择B 型车而不选择A 型车呢?相关专家透露，标准的B 型车车体的长度、宽度要小于A 型车，所以B</a:t>
             </a:r>
           </a:p>
           <a:p>
@@ -12721,7 +12874,7 @@
                 </a:solidFill>
                 <a:latin typeface="SimSun"/>
               </a:rPr>
-              <a:t>【巩固训练】阅读下面两则材料，完成练习。</a:t>
+              <a:t>型车比A 型车造价便宜得多，开挖地铁站时土建结构造价成本也随之下降。目前北京所有的地铁均选用B 型车，</a:t>
             </a:r>
           </a:p>
           <a:p>
@@ -12743,7 +12896,8 @@
                 </a:solidFill>
                 <a:latin typeface="SimSun"/>
               </a:rPr>
-              <a:t>【材料一】</a:t>
+              <a:t>我国拥有地铁的城市绝大多数采用B 型车。
+【材料二】</a:t>
             </a:r>
           </a:p>
           <a:p>
@@ -12765,7 +12919,7 @@
                 </a:solidFill>
                 <a:latin typeface="SimSun"/>
               </a:rPr>
-              <a:t>【图表占位：请参照原 PDF 图表】</a:t>
+              <a:t>【材料三】</a:t>
             </a:r>
           </a:p>
         </p:txBody>
@@ -12786,8 +12940,32 @@
         </p:blipFill>
         <p:spPr>
           <a:xfrm>
-            <a:off x="4651937" y="4307840"/>
-            <a:ext cx="2888123" cy="2194560"/>
+            <a:off x="1440664" y="4307840"/>
+            <a:ext cx="4106211" cy="2194560"/>
+          </a:xfrm>
+          <a:prstGeom prst="rect">
+            <a:avLst/>
+          </a:prstGeom>
+        </p:spPr>
+      </p:pic>
+      <p:pic>
+        <p:nvPicPr>
+          <p:cNvPr id="4" name="Picture 3" descr="image.jpg"/>
+          <p:cNvPicPr>
+            <a:picLocks noChangeAspect="1"/>
+          </p:cNvPicPr>
+          <p:nvPr/>
+        </p:nvPicPr>
+        <p:blipFill>
+          <a:blip r:embed="rId3"/>
+          <a:stretch>
+            <a:fillRect/>
+          </a:stretch>
+        </p:blipFill>
+        <p:spPr>
+          <a:xfrm>
+            <a:off x="5699275" y="4728464"/>
+            <a:ext cx="5052059" cy="1353311"/>
           </a:xfrm>
           <a:prstGeom prst="rect">
             <a:avLst/>
@@ -12802,7 +12980,7 @@
 </p:sld>
 </file>
 
-<file path=ppt/slides/slide57.xml><?xml version="1.0" encoding="utf-8"?>
+<file path=ppt/slides/slide58.xml><?xml version="1.0" encoding="utf-8"?>
 <p:sld xmlns:a="http://schemas.openxmlformats.org/drawingml/2006/main" xmlns:p="http://schemas.openxmlformats.org/presentationml/2006/main" xmlns:r="http://schemas.openxmlformats.org/officeDocument/2006/relationships">
   <p:cSld>
     <p:spTree>
@@ -12846,327 +13024,149 @@
               </a:spcAft>
             </a:pPr>
             <a:r>
-              <a:rPr sz="2200" b="0" i="0">
-                <a:solidFill>
-                  <a:srgbClr val="000000"/>
-                </a:solidFill>
-                <a:latin typeface="SimSun"/>
-              </a:rPr>
-              <a:t>为什么选择B 型车而不选择A 型车呢?相关专家透露，标准的B 型车车体的长度、宽度要小于A 型车，所以B</a:t>
-            </a:r>
-          </a:p>
-          <a:p>
-            <a:pPr algn="l">
-              <a:lnSpc>
-                <a:spcPct val="100000"/>
-              </a:lnSpc>
-              <a:spcBef>
-                <a:spcPts val="0"/>
-              </a:spcBef>
-              <a:spcAft>
-                <a:spcPts val="500"/>
-              </a:spcAft>
-            </a:pPr>
-            <a:r>
-              <a:rPr sz="2200" b="0" i="0">
-                <a:solidFill>
-                  <a:srgbClr val="000000"/>
-                </a:solidFill>
-                <a:latin typeface="SimSun"/>
-              </a:rPr>
-              <a:t>型车比A 型车造价便宜得多，开挖地铁站时土建结构造价成本也随之下降。目前北京所有的地铁均选用B 型车，</a:t>
-            </a:r>
-          </a:p>
-          <a:p>
-            <a:pPr algn="l">
-              <a:lnSpc>
-                <a:spcPct val="100000"/>
-              </a:lnSpc>
-              <a:spcBef>
-                <a:spcPts val="0"/>
-              </a:spcBef>
-              <a:spcAft>
-                <a:spcPts val="500"/>
-              </a:spcAft>
-            </a:pPr>
-            <a:r>
-              <a:rPr sz="2200" b="0" i="0">
-                <a:solidFill>
-                  <a:srgbClr val="000000"/>
-                </a:solidFill>
-                <a:latin typeface="SimSun"/>
-              </a:rPr>
-              <a:t>我国拥有地铁的城市绝大多数采用B 型车。
-【材料二】</a:t>
-            </a:r>
-          </a:p>
-          <a:p>
-            <a:pPr algn="l">
-              <a:lnSpc>
-                <a:spcPct val="100000"/>
-              </a:lnSpc>
-              <a:spcBef>
-                <a:spcPts val="0"/>
-              </a:spcBef>
-              <a:spcAft>
-                <a:spcPts val="500"/>
-              </a:spcAft>
-            </a:pPr>
-            <a:r>
-              <a:rPr sz="2200" b="0" i="0">
-                <a:solidFill>
-                  <a:srgbClr val="000000"/>
-                </a:solidFill>
-                <a:latin typeface="SimSun"/>
-              </a:rPr>
-              <a:t>【材料三】</a:t>
+              <a:rPr sz="1500" b="0" i="0">
+                <a:solidFill>
+                  <a:srgbClr val="000000"/>
+                </a:solidFill>
+                <a:latin typeface="SimSun"/>
+              </a:rPr>
+              <a:t>任务1：请你为“东莞地铁宣传栏”拟一条合适的宣传标语。(2 分)</a:t>
+            </a:r>
+          </a:p>
+          <a:p>
+            <a:pPr algn="l">
+              <a:lnSpc>
+                <a:spcPct val="100000"/>
+              </a:lnSpc>
+              <a:spcBef>
+                <a:spcPts val="0"/>
+              </a:spcBef>
+              <a:spcAft>
+                <a:spcPts val="500"/>
+              </a:spcAft>
+            </a:pPr>
+            <a:r>
+              <a:rPr sz="1500" b="0" i="0">
+                <a:solidFill>
+                  <a:srgbClr val="000000"/>
+                </a:solidFill>
+                <a:latin typeface="SimSun"/>
+              </a:rPr>
+              <a:t>任务2：复兴小学二年级学生参观东莞地铁，他们想知道如何买地铁票，你应推荐他们阅读宣传栏中的材料</a:t>
+            </a:r>
+          </a:p>
+          <a:p>
+            <a:pPr algn="l">
+              <a:lnSpc>
+                <a:spcPct val="100000"/>
+              </a:lnSpc>
+              <a:spcBef>
+                <a:spcPts val="0"/>
+              </a:spcBef>
+              <a:spcAft>
+                <a:spcPts val="500"/>
+              </a:spcAft>
+            </a:pPr>
+            <a:r>
+              <a:rPr sz="1500" b="0" i="0">
+                <a:solidFill>
+                  <a:srgbClr val="000000"/>
+                </a:solidFill>
+                <a:latin typeface="SimSun"/>
+              </a:rPr>
+              <a:t>；有同学想知道东莞规划了哪几条地铁，你应推荐他们阅读材料；还有同学想了解东莞地铁的时速，</a:t>
+            </a:r>
+          </a:p>
+          <a:p>
+            <a:pPr algn="l">
+              <a:lnSpc>
+                <a:spcPct val="100000"/>
+              </a:lnSpc>
+              <a:spcBef>
+                <a:spcPts val="0"/>
+              </a:spcBef>
+              <a:spcAft>
+                <a:spcPts val="500"/>
+              </a:spcAft>
+            </a:pPr>
+            <a:r>
+              <a:rPr sz="1500" b="0" i="0">
+                <a:solidFill>
+                  <a:srgbClr val="000000"/>
+                </a:solidFill>
+                <a:latin typeface="SimSun"/>
+              </a:rPr>
+              <a:t>你应推荐他们阅读材料。(3 分)</a:t>
+            </a:r>
+          </a:p>
+          <a:p>
+            <a:pPr algn="l">
+              <a:lnSpc>
+                <a:spcPct val="100000"/>
+              </a:lnSpc>
+              <a:spcBef>
+                <a:spcPts val="0"/>
+              </a:spcBef>
+              <a:spcAft>
+                <a:spcPts val="500"/>
+              </a:spcAft>
+            </a:pPr>
+            <a:r>
+              <a:rPr sz="1500" b="0" i="0">
+                <a:solidFill>
+                  <a:srgbClr val="000000"/>
+                </a:solidFill>
+                <a:latin typeface="SimSun"/>
+              </a:rPr>
+              <a:t>任务3：二年级学生阅读材料一有困难，请你为他们介绍东莞轨道交通运行系统选择的车型及选择原因。(3 分)</a:t>
+            </a:r>
+          </a:p>
+          <a:p>
+            <a:pPr algn="l">
+              <a:lnSpc>
+                <a:spcPct val="100000"/>
+              </a:lnSpc>
+              <a:spcBef>
+                <a:spcPts val="0"/>
+              </a:spcBef>
+              <a:spcAft>
+                <a:spcPts val="500"/>
+              </a:spcAft>
+            </a:pPr>
+            <a:r>
+              <a:rPr sz="1500" b="0" i="0">
+                <a:solidFill>
+                  <a:srgbClr val="000000"/>
+                </a:solidFill>
+                <a:latin typeface="SimSun"/>
+              </a:rPr>
+              <a:t>任务4：家住塘厦镇政府附近的张爷爷打来电话咨询，他要去茶山看孙子，请你告诉张爷爷他该如何换乘才用时最少，注意要提醒他换乘地点和方向。(3 分)</a:t>
+            </a:r>
+          </a:p>
+          <a:p>
+            <a:pPr algn="l">
+              <a:lnSpc>
+                <a:spcPct val="100000"/>
+              </a:lnSpc>
+              <a:spcBef>
+                <a:spcPts val="0"/>
+              </a:spcBef>
+              <a:spcAft>
+                <a:spcPts val="500"/>
+              </a:spcAft>
+            </a:pPr>
+            <a:r>
+              <a:rPr sz="1500" b="0" i="0">
+                <a:solidFill>
+                  <a:srgbClr val="000000"/>
+                </a:solidFill>
+                <a:latin typeface="SimSun"/>
+              </a:rPr>
+              <a:t>任务5：张爷爷年纪大了，没有手机支付，准备带现金买票。塘厦镇政府到茶山的票价为9 元，请你根据地铁自动售票机的使用规则，提醒张爷爷带现金的注意事项。(3 分)</a:t>
             </a:r>
           </a:p>
         </p:txBody>
       </p:sp>
-    </p:spTree>
-  </p:cSld>
-  <p:clrMapOvr>
-    <a:masterClrMapping/>
-  </p:clrMapOvr>
-</p:sld>
-</file>
-
-<file path=ppt/slides/slide58.xml><?xml version="1.0" encoding="utf-8"?>
-<p:sld xmlns:a="http://schemas.openxmlformats.org/drawingml/2006/main" xmlns:p="http://schemas.openxmlformats.org/presentationml/2006/main" xmlns:r="http://schemas.openxmlformats.org/officeDocument/2006/relationships">
-  <p:cSld>
-    <p:spTree>
-      <p:nvGrpSpPr>
-        <p:cNvPr id="1" name=""/>
-        <p:cNvGrpSpPr/>
-        <p:nvPr/>
-      </p:nvGrpSpPr>
-      <p:grpSpPr/>
-      <p:sp>
-        <p:nvSpPr>
-          <p:cNvPr id="2" name="TextBox 1"/>
-          <p:cNvSpPr txBox="1"/>
-          <p:nvPr/>
-        </p:nvSpPr>
-        <p:spPr>
-          <a:xfrm>
-            <a:off x="711200" y="355600"/>
-            <a:ext cx="10769599" cy="3733799"/>
-          </a:xfrm>
-          <a:prstGeom prst="rect">
-            <a:avLst/>
-          </a:prstGeom>
-          <a:noFill/>
-        </p:spPr>
-        <p:txBody>
-          <a:bodyPr wrap="square" lIns="101600" rIns="101600" tIns="38100" bIns="38100" anchor="t">
-            <a:normAutofit/>
-          </a:bodyPr>
-          <a:lstStyle/>
-          <a:p>
-            <a:pPr algn="l">
-              <a:lnSpc>
-                <a:spcPct val="100000"/>
-              </a:lnSpc>
-              <a:spcBef>
-                <a:spcPts val="0"/>
-              </a:spcBef>
-              <a:spcAft>
-                <a:spcPts val="500"/>
-              </a:spcAft>
-            </a:pPr>
-            <a:r>
-              <a:rPr sz="1500" b="0" i="0">
-                <a:solidFill>
-                  <a:srgbClr val="000000"/>
-                </a:solidFill>
-                <a:latin typeface="SimSun"/>
-              </a:rPr>
-              <a:t>任务1：请你为“东莞地铁宣传栏”拟一条合适的宣传标语。(2 分)</a:t>
-            </a:r>
-          </a:p>
-          <a:p>
-            <a:pPr algn="l">
-              <a:lnSpc>
-                <a:spcPct val="100000"/>
-              </a:lnSpc>
-              <a:spcBef>
-                <a:spcPts val="0"/>
-              </a:spcBef>
-              <a:spcAft>
-                <a:spcPts val="500"/>
-              </a:spcAft>
-            </a:pPr>
-            <a:r>
-              <a:rPr sz="1500" b="0" i="0">
-                <a:solidFill>
-                  <a:srgbClr val="000000"/>
-                </a:solidFill>
-                <a:latin typeface="SimSun"/>
-              </a:rPr>
-              <a:t>任务2：复兴小学二年级学生参观东莞地铁，他们想知道如何买地铁票，你应推荐他们阅读宣传栏中的材料</a:t>
-            </a:r>
-          </a:p>
-          <a:p>
-            <a:pPr algn="l">
-              <a:lnSpc>
-                <a:spcPct val="100000"/>
-              </a:lnSpc>
-              <a:spcBef>
-                <a:spcPts val="0"/>
-              </a:spcBef>
-              <a:spcAft>
-                <a:spcPts val="500"/>
-              </a:spcAft>
-            </a:pPr>
-            <a:r>
-              <a:rPr sz="1500" b="0" i="0">
-                <a:solidFill>
-                  <a:srgbClr val="000000"/>
-                </a:solidFill>
-                <a:latin typeface="SimSun"/>
-              </a:rPr>
-              <a:t>；有同学想知道东莞规划了哪几条地铁，你应推荐他们阅读材料；还有同学想了解东莞地铁的时速，</a:t>
-            </a:r>
-          </a:p>
-          <a:p>
-            <a:pPr algn="l">
-              <a:lnSpc>
-                <a:spcPct val="100000"/>
-              </a:lnSpc>
-              <a:spcBef>
-                <a:spcPts val="0"/>
-              </a:spcBef>
-              <a:spcAft>
-                <a:spcPts val="500"/>
-              </a:spcAft>
-            </a:pPr>
-            <a:r>
-              <a:rPr sz="1500" b="0" i="0">
-                <a:solidFill>
-                  <a:srgbClr val="000000"/>
-                </a:solidFill>
-                <a:latin typeface="SimSun"/>
-              </a:rPr>
-              <a:t>你应推荐他们阅读材料。(3 分)</a:t>
-            </a:r>
-          </a:p>
-          <a:p>
-            <a:pPr algn="l">
-              <a:lnSpc>
-                <a:spcPct val="100000"/>
-              </a:lnSpc>
-              <a:spcBef>
-                <a:spcPts val="0"/>
-              </a:spcBef>
-              <a:spcAft>
-                <a:spcPts val="500"/>
-              </a:spcAft>
-            </a:pPr>
-            <a:r>
-              <a:rPr sz="1500" b="0" i="0">
-                <a:solidFill>
-                  <a:srgbClr val="000000"/>
-                </a:solidFill>
-                <a:latin typeface="SimSun"/>
-              </a:rPr>
-              <a:t>任务3：二年级学生阅读材料一有困难，请你为他们介绍东莞轨道交通运行系统选择的车型及选择原因。(3 分)</a:t>
-            </a:r>
-          </a:p>
-          <a:p>
-            <a:pPr algn="l">
-              <a:lnSpc>
-                <a:spcPct val="100000"/>
-              </a:lnSpc>
-              <a:spcBef>
-                <a:spcPts val="0"/>
-              </a:spcBef>
-              <a:spcAft>
-                <a:spcPts val="500"/>
-              </a:spcAft>
-            </a:pPr>
-            <a:r>
-              <a:rPr sz="1500" b="0" i="0">
-                <a:solidFill>
-                  <a:srgbClr val="000000"/>
-                </a:solidFill>
-                <a:latin typeface="SimSun"/>
-              </a:rPr>
-              <a:t>任务4：家住塘厦镇政府附近的张爷爷打来电话咨询，他要去茶山看孙子，请你告诉张爷爷他该如何换乘才用时最少，注意要提醒他换乘地点和方向。(3 分)</a:t>
-            </a:r>
-          </a:p>
-          <a:p>
-            <a:pPr algn="l">
-              <a:lnSpc>
-                <a:spcPct val="100000"/>
-              </a:lnSpc>
-              <a:spcBef>
-                <a:spcPts val="0"/>
-              </a:spcBef>
-              <a:spcAft>
-                <a:spcPts val="500"/>
-              </a:spcAft>
-            </a:pPr>
-            <a:r>
-              <a:rPr sz="1500" b="0" i="0">
-                <a:solidFill>
-                  <a:srgbClr val="000000"/>
-                </a:solidFill>
-                <a:latin typeface="SimSun"/>
-              </a:rPr>
-              <a:t>任务5：张爷爷年纪大了，没有手机支付，准备带现金买票。塘厦镇政府到茶山的票价为9 元，请你根据地铁自动售票机的使用规则，提醒张爷爷带现金的注意事项。(3 分)</a:t>
-            </a:r>
-          </a:p>
-        </p:txBody>
-      </p:sp>
-      <p:pic>
-        <p:nvPicPr>
-          <p:cNvPr id="3" name="Picture 2" descr="image.jpg"/>
-          <p:cNvPicPr>
-            <a:picLocks noChangeAspect="1"/>
-          </p:cNvPicPr>
-          <p:nvPr/>
-        </p:nvPicPr>
-        <p:blipFill>
-          <a:blip r:embed="rId2"/>
-          <a:stretch>
-            <a:fillRect/>
-          </a:stretch>
-        </p:blipFill>
-        <p:spPr>
-          <a:xfrm>
-            <a:off x="1339179" y="4307840"/>
-            <a:ext cx="4052640" cy="2194560"/>
-          </a:xfrm>
-          <a:prstGeom prst="rect">
-            <a:avLst/>
-          </a:prstGeom>
-        </p:spPr>
-      </p:pic>
-      <p:pic>
-        <p:nvPicPr>
-          <p:cNvPr id="4" name="Picture 3" descr="image.jpg"/>
-          <p:cNvPicPr>
-            <a:picLocks noChangeAspect="1"/>
-          </p:cNvPicPr>
-          <p:nvPr/>
-        </p:nvPicPr>
-        <p:blipFill>
-          <a:blip r:embed="rId3"/>
-          <a:stretch>
-            <a:fillRect/>
-          </a:stretch>
-        </p:blipFill>
-        <p:spPr>
-          <a:xfrm>
-            <a:off x="5544220" y="4694520"/>
-            <a:ext cx="5308599" cy="1421199"/>
-          </a:xfrm>
-          <a:prstGeom prst="rect">
-            <a:avLst/>
-          </a:prstGeom>
-        </p:spPr>
-      </p:pic>
     </p:spTree>
   </p:cSld>
   <p:clrMapOvr>

</xml_diff>

<commit_message>
Release v0.5 with answer precheck
</commit_message>
<xml_diff>
--- a/mypaper_clean_no_answers.pptx
+++ b/mypaper_clean_no_answers.pptx
@@ -3181,7 +3181,7 @@
               </a:spcAft>
             </a:pPr>
             <a:r>
-              <a:rPr sz="2500" b="1" i="0">
+              <a:rPr sz="2400" b="1" i="0">
                 <a:solidFill>
                   <a:srgbClr val="FF0000"/>
                 </a:solidFill>
@@ -3203,7 +3203,7 @@
               </a:spcAft>
             </a:pPr>
             <a:r>
-              <a:rPr sz="2500" b="1" i="0">
+              <a:rPr sz="2400" b="1" i="0">
                 <a:solidFill>
                   <a:srgbClr val="EF939E"/>
                 </a:solidFill>
@@ -3225,7 +3225,7 @@
               </a:spcAft>
             </a:pPr>
             <a:r>
-              <a:rPr sz="2500" b="1" i="0">
+              <a:rPr sz="2400" b="1" i="0">
                 <a:solidFill>
                   <a:srgbClr val="EE822F"/>
                 </a:solidFill>
@@ -3247,7 +3247,7 @@
               </a:spcAft>
             </a:pPr>
             <a:r>
-              <a:rPr sz="2500" b="1" i="0">
+              <a:rPr sz="2400" b="1" i="0">
                 <a:solidFill>
                   <a:srgbClr val="C55E10"/>
                 </a:solidFill>
@@ -3310,7 +3310,7 @@
               </a:spcAft>
             </a:pPr>
             <a:r>
-              <a:rPr sz="1800" b="1" i="0">
+              <a:rPr sz="1700" b="1" i="0">
                 <a:solidFill>
                   <a:srgbClr val="FF0000"/>
                 </a:solidFill>
@@ -3332,7 +3332,7 @@
               </a:spcAft>
             </a:pPr>
             <a:r>
-              <a:rPr sz="1800" b="1" i="0">
+              <a:rPr sz="1700" b="1" i="0">
                 <a:solidFill>
                   <a:srgbClr val="C55E10"/>
                 </a:solidFill>
@@ -3854,7 +3854,7 @@
               </a:spcAft>
             </a:pPr>
             <a:r>
-              <a:rPr sz="2100" b="1" i="0">
+              <a:rPr sz="2000" b="1" i="0">
                 <a:solidFill>
                   <a:srgbClr val="FF0000"/>
                 </a:solidFill>
@@ -3876,7 +3876,7 @@
               </a:spcAft>
             </a:pPr>
             <a:r>
-              <a:rPr sz="2100" b="1" i="0">
+              <a:rPr sz="2000" b="1" i="0">
                 <a:solidFill>
                   <a:srgbClr val="C55E10"/>
                 </a:solidFill>
@@ -3898,7 +3898,7 @@
               </a:spcAft>
             </a:pPr>
             <a:r>
-              <a:rPr sz="2100" b="1" i="0">
+              <a:rPr sz="2000" b="1" i="0">
                 <a:solidFill>
                   <a:srgbClr val="2D54A0"/>
                 </a:solidFill>
@@ -4073,7 +4073,7 @@
               </a:spcAft>
             </a:pPr>
             <a:r>
-              <a:rPr sz="2100" b="1" i="0">
+              <a:rPr sz="2000" b="1" i="0">
                 <a:solidFill>
                   <a:srgbClr val="FF0000"/>
                 </a:solidFill>
@@ -4095,7 +4095,7 @@
               </a:spcAft>
             </a:pPr>
             <a:r>
-              <a:rPr sz="2100" b="1" i="0">
+              <a:rPr sz="2000" b="1" i="0">
                 <a:solidFill>
                   <a:srgbClr val="C55E10"/>
                 </a:solidFill>
@@ -4117,7 +4117,7 @@
               </a:spcAft>
             </a:pPr>
             <a:r>
-              <a:rPr sz="2100" b="1" i="0">
+              <a:rPr sz="2000" b="1" i="0">
                 <a:solidFill>
                   <a:srgbClr val="2D54A0"/>
                 </a:solidFill>
@@ -4294,7 +4294,7 @@
               </a:spcAft>
             </a:pPr>
             <a:r>
-              <a:rPr sz="2100" b="1" i="0">
+              <a:rPr sz="2000" b="1" i="0">
                 <a:solidFill>
                   <a:srgbClr val="FF0000"/>
                 </a:solidFill>
@@ -4316,7 +4316,7 @@
               </a:spcAft>
             </a:pPr>
             <a:r>
-              <a:rPr sz="2100" b="1" i="0">
+              <a:rPr sz="2000" b="1" i="0">
                 <a:solidFill>
                   <a:srgbClr val="C55E10"/>
                 </a:solidFill>
@@ -4338,7 +4338,7 @@
               </a:spcAft>
             </a:pPr>
             <a:r>
-              <a:rPr sz="2100" b="1" i="0">
+              <a:rPr sz="2000" b="1" i="0">
                 <a:solidFill>
                   <a:srgbClr val="2D54A0"/>
                 </a:solidFill>
@@ -4535,7 +4535,7 @@
               </a:spcAft>
             </a:pPr>
             <a:r>
-              <a:rPr sz="1800" b="1" i="0">
+              <a:rPr sz="1700" b="1" i="0">
                 <a:solidFill>
                   <a:srgbClr val="FF0000"/>
                 </a:solidFill>
@@ -4557,7 +4557,7 @@
               </a:spcAft>
             </a:pPr>
             <a:r>
-              <a:rPr sz="1800" b="1" i="0">
+              <a:rPr sz="1700" b="1" i="0">
                 <a:solidFill>
                   <a:srgbClr val="C55E10"/>
                 </a:solidFill>
@@ -4579,7 +4579,7 @@
               </a:spcAft>
             </a:pPr>
             <a:r>
-              <a:rPr sz="1800" b="1" i="0">
+              <a:rPr sz="1700" b="1" i="0">
                 <a:solidFill>
                   <a:srgbClr val="2D54A0"/>
                 </a:solidFill>
@@ -4756,7 +4756,7 @@
               </a:spcAft>
             </a:pPr>
             <a:r>
-              <a:rPr sz="1800" b="1" i="0">
+              <a:rPr sz="1700" b="1" i="0">
                 <a:solidFill>
                   <a:srgbClr val="FF0000"/>
                 </a:solidFill>
@@ -4778,7 +4778,7 @@
               </a:spcAft>
             </a:pPr>
             <a:r>
-              <a:rPr sz="1800" b="1" i="0">
+              <a:rPr sz="1700" b="1" i="0">
                 <a:solidFill>
                   <a:srgbClr val="C55E10"/>
                 </a:solidFill>
@@ -4800,7 +4800,7 @@
               </a:spcAft>
             </a:pPr>
             <a:r>
-              <a:rPr sz="1800" b="1" i="0">
+              <a:rPr sz="1700" b="1" i="0">
                 <a:solidFill>
                   <a:srgbClr val="2D54A0"/>
                 </a:solidFill>
@@ -4975,7 +4975,7 @@
               </a:spcAft>
             </a:pPr>
             <a:r>
-              <a:rPr sz="2100" b="1" i="0">
+              <a:rPr sz="2000" b="1" i="0">
                 <a:solidFill>
                   <a:srgbClr val="FF0000"/>
                 </a:solidFill>
@@ -4997,7 +4997,7 @@
               </a:spcAft>
             </a:pPr>
             <a:r>
-              <a:rPr sz="2100" b="1" i="0">
+              <a:rPr sz="2000" b="1" i="0">
                 <a:solidFill>
                   <a:srgbClr val="C55E10"/>
                 </a:solidFill>
@@ -5019,7 +5019,7 @@
               </a:spcAft>
             </a:pPr>
             <a:r>
-              <a:rPr sz="2100" b="1" i="0">
+              <a:rPr sz="2000" b="1" i="0">
                 <a:solidFill>
                   <a:srgbClr val="2D54A0"/>
                 </a:solidFill>
@@ -5196,7 +5196,7 @@
               </a:spcAft>
             </a:pPr>
             <a:r>
-              <a:rPr sz="1800" b="1" i="0">
+              <a:rPr sz="1700" b="1" i="0">
                 <a:solidFill>
                   <a:srgbClr val="FF0000"/>
                 </a:solidFill>
@@ -5218,7 +5218,7 @@
               </a:spcAft>
             </a:pPr>
             <a:r>
-              <a:rPr sz="1800" b="1" i="0">
+              <a:rPr sz="1700" b="1" i="0">
                 <a:solidFill>
                   <a:srgbClr val="C55E10"/>
                 </a:solidFill>
@@ -5393,7 +5393,7 @@
               </a:spcAft>
             </a:pPr>
             <a:r>
-              <a:rPr sz="2100" b="1" i="0">
+              <a:rPr sz="2000" b="1" i="0">
                 <a:solidFill>
                   <a:srgbClr val="FF0000"/>
                 </a:solidFill>
@@ -5415,7 +5415,7 @@
               </a:spcAft>
             </a:pPr>
             <a:r>
-              <a:rPr sz="2100" b="1" i="0">
+              <a:rPr sz="2000" b="1" i="0">
                 <a:solidFill>
                   <a:srgbClr val="C55E10"/>
                 </a:solidFill>
@@ -5437,7 +5437,7 @@
               </a:spcAft>
             </a:pPr>
             <a:r>
-              <a:rPr sz="2100" b="1" i="0">
+              <a:rPr sz="2000" b="1" i="0">
                 <a:solidFill>
                   <a:srgbClr val="2D54A0"/>
                 </a:solidFill>
@@ -5637,7 +5637,7 @@
               </a:spcAft>
             </a:pPr>
             <a:r>
-              <a:rPr sz="1800" b="1" i="0">
+              <a:rPr sz="1700" b="1" i="0">
                 <a:solidFill>
                   <a:srgbClr val="FF0000"/>
                 </a:solidFill>
@@ -5681,7 +5681,7 @@
               </a:spcAft>
             </a:pPr>
             <a:r>
-              <a:rPr sz="1800" b="1" i="0">
+              <a:rPr sz="1700" b="1" i="0">
                 <a:solidFill>
                   <a:srgbClr val="2D54A0"/>
                 </a:solidFill>
@@ -5880,7 +5880,7 @@
               </a:spcAft>
             </a:pPr>
             <a:r>
-              <a:rPr sz="1800" b="1" i="0">
+              <a:rPr sz="1700" b="1" i="0">
                 <a:solidFill>
                   <a:srgbClr val="FF0000"/>
                 </a:solidFill>
@@ -5924,7 +5924,7 @@
               </a:spcAft>
             </a:pPr>
             <a:r>
-              <a:rPr sz="1800" b="1" i="0">
+              <a:rPr sz="1700" b="1" i="0">
                 <a:solidFill>
                   <a:srgbClr val="2D54A0"/>
                 </a:solidFill>
@@ -6102,7 +6102,7 @@
               </a:spcAft>
             </a:pPr>
             <a:r>
-              <a:rPr sz="1800" b="1" i="0">
+              <a:rPr sz="1700" b="1" i="0">
                 <a:solidFill>
                   <a:srgbClr val="FF0000"/>
                 </a:solidFill>
@@ -6146,7 +6146,7 @@
               </a:spcAft>
             </a:pPr>
             <a:r>
-              <a:rPr sz="1800" b="1" i="0">
+              <a:rPr sz="1700" b="1" i="0">
                 <a:solidFill>
                   <a:srgbClr val="2D54A0"/>
                 </a:solidFill>
@@ -6367,7 +6367,7 @@
               </a:spcAft>
             </a:pPr>
             <a:r>
-              <a:rPr sz="2100" b="1" i="0">
+              <a:rPr sz="2000" b="1" i="0">
                 <a:solidFill>
                   <a:srgbClr val="FF0000"/>
                 </a:solidFill>
@@ -6411,7 +6411,7 @@
               </a:spcAft>
             </a:pPr>
             <a:r>
-              <a:rPr sz="2100" b="1" i="0">
+              <a:rPr sz="2000" b="1" i="0">
                 <a:solidFill>
                   <a:srgbClr val="2D54A0"/>
                 </a:solidFill>
@@ -6673,7 +6673,7 @@
               </a:spcAft>
             </a:pPr>
             <a:r>
-              <a:rPr sz="1800" b="1" i="0">
+              <a:rPr sz="1700" b="1" i="0">
                 <a:solidFill>
                   <a:srgbClr val="FF0000"/>
                 </a:solidFill>
@@ -6717,7 +6717,7 @@
               </a:spcAft>
             </a:pPr>
             <a:r>
-              <a:rPr sz="1800" b="1" i="0">
+              <a:rPr sz="1700" b="1" i="0">
                 <a:solidFill>
                   <a:srgbClr val="2D54A0"/>
                 </a:solidFill>
@@ -6937,7 +6937,7 @@
               </a:spcAft>
             </a:pPr>
             <a:r>
-              <a:rPr sz="1800" b="1" i="0">
+              <a:rPr sz="1700" b="1" i="0">
                 <a:solidFill>
                   <a:srgbClr val="FF0000"/>
                 </a:solidFill>
@@ -6981,7 +6981,7 @@
               </a:spcAft>
             </a:pPr>
             <a:r>
-              <a:rPr sz="1800" b="1" i="0">
+              <a:rPr sz="1700" b="1" i="0">
                 <a:solidFill>
                   <a:srgbClr val="2D54A0"/>
                 </a:solidFill>
@@ -7470,7 +7470,7 @@
               </a:spcAft>
             </a:pPr>
             <a:r>
-              <a:rPr sz="1800" b="1" i="0">
+              <a:rPr sz="1700" b="1" i="0">
                 <a:solidFill>
                   <a:srgbClr val="FF0000"/>
                 </a:solidFill>
@@ -7492,7 +7492,7 @@
               </a:spcAft>
             </a:pPr>
             <a:r>
-              <a:rPr sz="1800" b="1" i="0">
+              <a:rPr sz="1700" b="1" i="0">
                 <a:solidFill>
                   <a:srgbClr val="C55E10"/>
                 </a:solidFill>
@@ -8038,7 +8038,7 @@
               </a:spcAft>
             </a:pPr>
             <a:r>
-              <a:rPr sz="1800" b="1" i="0">
+              <a:rPr sz="1700" b="1" i="0">
                 <a:solidFill>
                   <a:srgbClr val="FF0000"/>
                 </a:solidFill>
@@ -8060,7 +8060,7 @@
               </a:spcAft>
             </a:pPr>
             <a:r>
-              <a:rPr sz="1800" b="1" i="0">
+              <a:rPr sz="1700" b="1" i="0">
                 <a:solidFill>
                   <a:srgbClr val="C55E10"/>
                 </a:solidFill>
@@ -9100,7 +9100,7 @@
               </a:spcAft>
             </a:pPr>
             <a:r>
-              <a:rPr sz="1800" b="1" i="0">
+              <a:rPr sz="1700" b="1" i="0">
                 <a:solidFill>
                   <a:srgbClr val="FF0000"/>
                 </a:solidFill>
@@ -9122,7 +9122,7 @@
               </a:spcAft>
             </a:pPr>
             <a:r>
-              <a:rPr sz="1800" b="1" i="0">
+              <a:rPr sz="1700" b="1" i="0">
                 <a:solidFill>
                   <a:srgbClr val="C55E10"/>
                 </a:solidFill>
@@ -9411,7 +9411,7 @@
               </a:spcAft>
             </a:pPr>
             <a:r>
-              <a:rPr sz="1800" b="1" i="0">
+              <a:rPr sz="1700" b="1" i="0">
                 <a:solidFill>
                   <a:srgbClr val="FF0000"/>
                 </a:solidFill>
@@ -9433,7 +9433,7 @@
               </a:spcAft>
             </a:pPr>
             <a:r>
-              <a:rPr sz="1800" b="1" i="0">
+              <a:rPr sz="1700" b="1" i="0">
                 <a:solidFill>
                   <a:srgbClr val="C55E10"/>
                 </a:solidFill>
@@ -9455,7 +9455,7 @@
               </a:spcAft>
             </a:pPr>
             <a:r>
-              <a:rPr sz="1800" b="1" i="0">
+              <a:rPr sz="1700" b="1" i="0">
                 <a:solidFill>
                   <a:srgbClr val="FF0000"/>
                 </a:solidFill>
@@ -9477,7 +9477,7 @@
               </a:spcAft>
             </a:pPr>
             <a:r>
-              <a:rPr sz="1800" b="1" i="0">
+              <a:rPr sz="1700" b="1" i="0">
                 <a:solidFill>
                   <a:srgbClr val="C55E10"/>
                 </a:solidFill>
@@ -9803,7 +9803,7 @@
               </a:spcAft>
             </a:pPr>
             <a:r>
-              <a:rPr sz="1800" b="1" i="0">
+              <a:rPr sz="1700" b="1" i="0">
                 <a:solidFill>
                   <a:srgbClr val="FF0000"/>
                 </a:solidFill>
@@ -9825,7 +9825,7 @@
               </a:spcAft>
             </a:pPr>
             <a:r>
-              <a:rPr sz="1800" b="1" i="0">
+              <a:rPr sz="1700" b="1" i="0">
                 <a:solidFill>
                   <a:srgbClr val="C55E10"/>
                 </a:solidFill>
@@ -10261,7 +10261,7 @@
               </a:spcAft>
             </a:pPr>
             <a:r>
-              <a:rPr sz="1800" b="1" i="0">
+              <a:rPr sz="1700" b="1" i="0">
                 <a:solidFill>
                   <a:srgbClr val="FF0000"/>
                 </a:solidFill>
@@ -10283,7 +10283,7 @@
               </a:spcAft>
             </a:pPr>
             <a:r>
-              <a:rPr sz="1800" b="1" i="0">
+              <a:rPr sz="1700" b="1" i="0">
                 <a:solidFill>
                   <a:srgbClr val="C55E10"/>
                 </a:solidFill>
@@ -10812,7 +10812,7 @@
               </a:spcAft>
             </a:pPr>
             <a:r>
-              <a:rPr sz="1800" b="1" i="0">
+              <a:rPr sz="1700" b="1" i="0">
                 <a:solidFill>
                   <a:srgbClr val="FF0000"/>
                 </a:solidFill>
@@ -10834,7 +10834,7 @@
               </a:spcAft>
             </a:pPr>
             <a:r>
-              <a:rPr sz="1800" b="1" i="0">
+              <a:rPr sz="1700" b="1" i="0">
                 <a:solidFill>
                   <a:srgbClr val="C55E10"/>
                 </a:solidFill>
@@ -10946,7 +10946,7 @@
               </a:spcAft>
             </a:pPr>
             <a:r>
-              <a:rPr sz="1800" b="1" i="0">
+              <a:rPr sz="1700" b="1" i="0">
                 <a:solidFill>
                   <a:srgbClr val="FF0000"/>
                 </a:solidFill>
@@ -10968,7 +10968,7 @@
               </a:spcAft>
             </a:pPr>
             <a:r>
-              <a:rPr sz="1800" b="1" i="0">
+              <a:rPr sz="1700" b="1" i="0">
                 <a:solidFill>
                   <a:srgbClr val="C55E10"/>
                 </a:solidFill>
@@ -11012,7 +11012,7 @@
               </a:spcAft>
             </a:pPr>
             <a:r>
-              <a:rPr sz="1800" b="1" i="0">
+              <a:rPr sz="1700" b="1" i="0">
                 <a:solidFill>
                   <a:srgbClr val="FF0000"/>
                 </a:solidFill>
@@ -11237,7 +11237,7 @@
               </a:spcAft>
             </a:pPr>
             <a:r>
-              <a:rPr sz="1800" b="1" i="0">
+              <a:rPr sz="1700" b="1" i="0">
                 <a:solidFill>
                   <a:srgbClr val="FF0000"/>
                 </a:solidFill>
@@ -11259,7 +11259,7 @@
               </a:spcAft>
             </a:pPr>
             <a:r>
-              <a:rPr sz="1800" b="1" i="0">
+              <a:rPr sz="1700" b="1" i="0">
                 <a:solidFill>
                   <a:srgbClr val="C55E10"/>
                 </a:solidFill>
@@ -11567,7 +11567,7 @@
               </a:spcAft>
             </a:pPr>
             <a:r>
-              <a:rPr sz="2500" b="1" i="0">
+              <a:rPr sz="2400" b="1" i="0">
                 <a:solidFill>
                   <a:srgbClr val="FF0000"/>
                 </a:solidFill>
@@ -11589,7 +11589,7 @@
               </a:spcAft>
             </a:pPr>
             <a:r>
-              <a:rPr sz="2500" b="1" i="0">
+              <a:rPr sz="2400" b="1" i="0">
                 <a:solidFill>
                   <a:srgbClr val="C55E10"/>
                 </a:solidFill>
@@ -11718,7 +11718,7 @@
               </a:spcAft>
             </a:pPr>
             <a:r>
-              <a:rPr sz="1800" b="1" i="0">
+              <a:rPr sz="1700" b="1" i="0">
                 <a:solidFill>
                   <a:srgbClr val="FF0000"/>
                 </a:solidFill>
@@ -12147,7 +12147,7 @@
               </a:spcAft>
             </a:pPr>
             <a:r>
-              <a:rPr sz="1800" b="1" i="0">
+              <a:rPr sz="1700" b="1" i="0">
                 <a:solidFill>
                   <a:srgbClr val="FF0000"/>
                 </a:solidFill>
@@ -12169,7 +12169,7 @@
               </a:spcAft>
             </a:pPr>
             <a:r>
-              <a:rPr sz="1800" b="1" i="0">
+              <a:rPr sz="1700" b="1" i="0">
                 <a:solidFill>
                   <a:srgbClr val="C55E10"/>
                 </a:solidFill>
@@ -12695,7 +12695,7 @@
               </a:spcAft>
             </a:pPr>
             <a:r>
-              <a:rPr sz="2500" b="1" i="0">
+              <a:rPr sz="2400" b="1" i="0">
                 <a:solidFill>
                   <a:srgbClr val="000000"/>
                 </a:solidFill>
@@ -12717,7 +12717,7 @@
               </a:spcAft>
             </a:pPr>
             <a:r>
-              <a:rPr sz="2500" b="1" i="0">
+              <a:rPr sz="2400" b="1" i="0">
                 <a:solidFill>
                   <a:srgbClr val="000000"/>
                 </a:solidFill>
@@ -13219,7 +13219,7 @@
               </a:spcAft>
             </a:pPr>
             <a:r>
-              <a:rPr sz="1800" b="1" i="0">
+              <a:rPr sz="1700" b="1" i="0">
                 <a:solidFill>
                   <a:srgbClr val="FF0000"/>
                 </a:solidFill>
@@ -13241,7 +13241,7 @@
               </a:spcAft>
             </a:pPr>
             <a:r>
-              <a:rPr sz="1800" b="1" i="0">
+              <a:rPr sz="1700" b="1" i="0">
                 <a:solidFill>
                   <a:srgbClr val="0000FF"/>
                 </a:solidFill>
@@ -13263,7 +13263,7 @@
               </a:spcAft>
             </a:pPr>
             <a:r>
-              <a:rPr sz="1800" b="1" i="0">
+              <a:rPr sz="1700" b="1" i="0">
                 <a:solidFill>
                   <a:srgbClr val="EE822F"/>
                 </a:solidFill>
@@ -13311,7 +13311,7 @@
               </a:spcAft>
             </a:pPr>
             <a:r>
-              <a:rPr sz="1800" b="1" i="0">
+              <a:rPr sz="1700" b="1" i="0">
                 <a:solidFill>
                   <a:srgbClr val="30C0B4"/>
                 </a:solidFill>
@@ -13374,7 +13374,7 @@
               </a:spcAft>
             </a:pPr>
             <a:r>
-              <a:rPr sz="1800" b="1" i="0">
+              <a:rPr sz="1700" b="1" i="0">
                 <a:solidFill>
                   <a:srgbClr val="FF0000"/>
                 </a:solidFill>
@@ -13396,7 +13396,7 @@
               </a:spcAft>
             </a:pPr>
             <a:r>
-              <a:rPr sz="1800" b="1" i="0">
+              <a:rPr sz="1700" b="1" i="0">
                 <a:solidFill>
                   <a:srgbClr val="C55E10"/>
                 </a:solidFill>

</xml_diff>